<commit_message>
Add Puzzle Realty logo and real Telegram QR code to the deck
Slide 1 and slide 15 now use the supplied logo. Slide 15 is a single
Telegram card (QR -> t.me/puzzlerealty) instead of two placeholder QR
cards. Updated in both the HTML and the .pptx versions.

Co-Authored-By: Claude Sonnet 5.5 <noreply@anthropic.com>
Claude-Session: https://claude.ai/code/session_01A2n4hdiEzWzMp1Q9LNSSiZ
</commit_message>
<xml_diff>
--- a/examples/developer-broker-synergy-Luxury.pptx
+++ b/examples/developer-broker-synergy-Luxury.pptx
@@ -1044,7 +1044,7 @@
           <a:p>
             <a:r>
               <a:rPr lang="en-US" dirty="0"/>
-              <a:t>Заменить серые квадраты QR-кодами. Что именно отдаём слушателям в блоке «Шаблоны» — предложение, согласовать с автором.</a:t>
+              <a:t>QR-код ведёт на Telegram-канал: https://t.me/puzzlerealty</a:t>
             </a:r>
             <a:endParaRPr lang="en-US" dirty="0"/>
           </a:p>
@@ -2153,7 +2153,7 @@
         </p:nvSpPr>
         <p:spPr>
           <a:xfrm>
-            <a:off x="731518" y="3596631"/>
+            <a:off x="731518" y="3267448"/>
             <a:ext cx="10728933" cy="1706876"/>
           </a:xfrm>
           <a:prstGeom prst="rect">
@@ -2195,7 +2195,7 @@
         </p:nvSpPr>
         <p:spPr>
           <a:xfrm>
-            <a:off x="1706876" y="5486386"/>
+            <a:off x="1706876" y="5145011"/>
             <a:ext cx="8778218" cy="560831"/>
           </a:xfrm>
           <a:prstGeom prst="rect">
@@ -2237,7 +2237,7 @@
         </p:nvSpPr>
         <p:spPr>
           <a:xfrm>
-            <a:off x="560831" y="6169137"/>
+            <a:off x="560831" y="5803377"/>
             <a:ext cx="11070308" cy="0"/>
           </a:xfrm>
           <a:prstGeom prst="line">
@@ -2262,72 +2262,52 @@
         </p:nvSpPr>
         <p:spPr>
           <a:xfrm>
-            <a:off x="560831" y="6352016"/>
-            <a:ext cx="2316474" cy="390143"/>
-          </a:xfrm>
-          <a:prstGeom prst="rect">
-            <a:avLst/>
-          </a:prstGeom>
-          <a:ln w="9525">
-            <a:solidFill>
-              <a:srgbClr val="C9A96E"/>
-            </a:solidFill>
-            <a:prstDash val="dash"/>
-          </a:ln>
-        </p:spPr>
-      </p:sp>
-      <p:sp>
-        <p:nvSpPr>
-          <p:cNvPr id="7" name="Text 4"/>
-          <p:cNvSpPr txBox="1"/>
-          <p:nvPr/>
-        </p:nvSpPr>
-        <p:spPr>
-          <a:xfrm>
-            <a:off x="560831" y="6352016"/>
-            <a:ext cx="2316474" cy="390143"/>
-          </a:xfrm>
-          <a:prstGeom prst="rect">
-            <a:avLst/>
-          </a:prstGeom>
-          <a:noFill/>
-          <a:ln/>
-        </p:spPr>
-        <p:txBody>
-          <a:bodyPr wrap="square" lIns="0" tIns="0" rIns="0" bIns="0" rtlCol="0" anchor="ctr"/>
-          <a:lstStyle/>
-          <a:p>
-            <a:pPr algn="ctr" indent="0" marL="0">
-              <a:lnSpc>
-                <a:spcPct val="100000"/>
-              </a:lnSpc>
-              <a:buNone/>
-            </a:pPr>
-            <a:r>
-              <a:rPr lang="en-US" sz="1100" spc="250" kern="0" dirty="0">
-                <a:solidFill>
-                  <a:srgbClr val="C9A96E"/>
-                </a:solidFill>
-                <a:latin typeface="Calibri" pitchFamily="34" charset="0"/>
-                <a:ea typeface="Calibri" pitchFamily="34" charset="-122"/>
-                <a:cs typeface="Calibri" pitchFamily="34" charset="-120"/>
-              </a:rPr>
-              <a:t>ЛОГОТИП АГЕНТСТВА</a:t>
-            </a:r>
-            <a:endParaRPr lang="en-US" sz="1100" dirty="0"/>
-          </a:p>
-        </p:txBody>
-      </p:sp>
-      <p:sp>
-        <p:nvSpPr>
-          <p:cNvPr id="8" name="Text 5"/>
-          <p:cNvSpPr txBox="1"/>
-          <p:nvPr/>
-        </p:nvSpPr>
-        <p:spPr>
-          <a:xfrm>
-            <a:off x="5364467" y="6291056"/>
-            <a:ext cx="6266672" cy="536447"/>
+            <a:off x="560831" y="5998449"/>
+            <a:ext cx="1511804" cy="633982"/>
+          </a:xfrm>
+          <a:prstGeom prst="rect">
+            <a:avLst/>
+          </a:prstGeom>
+          <a:solidFill>
+            <a:srgbClr val="FFFFFF"/>
+          </a:solidFill>
+          <a:ln/>
+        </p:spPr>
+      </p:sp>
+      <p:pic>
+        <p:nvPicPr>
+          <p:cNvPr id="7" name="Image 1" descr="/tmp/claude-0/-home-user-cjl-slides/dc4b3785-bf11-502a-8a99-927e98445714/scratchpad/pp/logo.png">    </p:cNvPr>
+          <p:cNvPicPr>
+            <a:picLocks noChangeAspect="1"/>
+          </p:cNvPicPr>
+          <p:nvPr/>
+        </p:nvPicPr>
+        <p:blipFill>
+          <a:blip r:embed="rId2"/>
+          <a:stretch>
+            <a:fillRect/>
+          </a:stretch>
+        </p:blipFill>
+        <p:spPr>
+          <a:xfrm>
+            <a:off x="670558" y="6108177"/>
+            <a:ext cx="1292349" cy="505112"/>
+          </a:xfrm>
+          <a:prstGeom prst="rect">
+            <a:avLst/>
+          </a:prstGeom>
+        </p:spPr>
+      </p:pic>
+      <p:sp>
+        <p:nvSpPr>
+          <p:cNvPr id="8" name="Text 4"/>
+          <p:cNvSpPr txBox="1"/>
+          <p:nvPr/>
+        </p:nvSpPr>
+        <p:spPr>
+          <a:xfrm>
+            <a:off x="5364467" y="5998449"/>
+            <a:ext cx="6266672" cy="633982"/>
           </a:xfrm>
           <a:prstGeom prst="rect">
             <a:avLst/>
@@ -6566,7 +6546,51 @@
       </p:sp>
       <p:sp>
         <p:nvSpPr>
-          <p:cNvPr id="5" name="Text 3"/>
+          <p:cNvPr id="5" name="Shape 3"/>
+          <p:cNvSpPr/>
+          <p:nvPr/>
+        </p:nvSpPr>
+        <p:spPr>
+          <a:xfrm>
+            <a:off x="560831" y="4949940"/>
+            <a:ext cx="1731260" cy="755902"/>
+          </a:xfrm>
+          <a:prstGeom prst="rect">
+            <a:avLst/>
+          </a:prstGeom>
+          <a:solidFill>
+            <a:srgbClr val="FFFFFF"/>
+          </a:solidFill>
+          <a:ln/>
+        </p:spPr>
+      </p:sp>
+      <p:pic>
+        <p:nvPicPr>
+          <p:cNvPr id="6" name="Image 0" descr="/tmp/claude-0/-home-user-cjl-slides/dc4b3785-bf11-502a-8a99-927e98445714/scratchpad/pp/logo.png">    </p:cNvPr>
+          <p:cNvPicPr>
+            <a:picLocks noChangeAspect="1"/>
+          </p:cNvPicPr>
+          <p:nvPr/>
+        </p:nvPicPr>
+        <p:blipFill>
+          <a:blip r:embed="rId1"/>
+          <a:stretch>
+            <a:fillRect/>
+          </a:stretch>
+        </p:blipFill>
+        <p:spPr>
+          <a:xfrm>
+            <a:off x="682750" y="5071859"/>
+            <a:ext cx="1487420" cy="581356"/>
+          </a:xfrm>
+          <a:prstGeom prst="rect">
+            <a:avLst/>
+          </a:prstGeom>
+        </p:spPr>
+      </p:pic>
+      <p:sp>
+        <p:nvSpPr>
+          <p:cNvPr id="7" name="Text 4"/>
           <p:cNvSpPr txBox="1"/>
           <p:nvPr/>
         </p:nvSpPr>
@@ -6628,14 +6652,14 @@
       </p:sp>
       <p:sp>
         <p:nvSpPr>
-          <p:cNvPr id="6" name="Shape 4"/>
+          <p:cNvPr id="8" name="Shape 5"/>
           <p:cNvSpPr/>
           <p:nvPr/>
         </p:nvSpPr>
         <p:spPr>
           <a:xfrm>
             <a:off x="5193779" y="512063"/>
-            <a:ext cx="3121144" cy="5827761"/>
+            <a:ext cx="6486128" cy="5827761"/>
           </a:xfrm>
           <a:prstGeom prst="rect">
             <a:avLst/>
@@ -6655,14 +6679,58 @@
       </p:sp>
       <p:sp>
         <p:nvSpPr>
-          <p:cNvPr id="7" name="Text 5"/>
-          <p:cNvSpPr txBox="1"/>
-          <p:nvPr/>
-        </p:nvSpPr>
-        <p:spPr>
-          <a:xfrm>
-            <a:off x="5462002" y="755902"/>
-            <a:ext cx="1219197" cy="487679"/>
+          <p:cNvPr id="9" name="Shape 6"/>
+          <p:cNvSpPr/>
+          <p:nvPr/>
+        </p:nvSpPr>
+        <p:spPr>
+          <a:xfrm>
+            <a:off x="5608306" y="1901947"/>
+            <a:ext cx="2999225" cy="2999225"/>
+          </a:xfrm>
+          <a:prstGeom prst="rect">
+            <a:avLst/>
+          </a:prstGeom>
+          <a:solidFill>
+            <a:srgbClr val="FFFFFF"/>
+          </a:solidFill>
+          <a:ln/>
+        </p:spPr>
+      </p:sp>
+      <p:pic>
+        <p:nvPicPr>
+          <p:cNvPr id="10" name="Image 1" descr="QR-код: t.me/puzzlerealty">    </p:cNvPr>
+          <p:cNvPicPr>
+            <a:picLocks noChangeAspect="1"/>
+          </p:cNvPicPr>
+          <p:nvPr/>
+        </p:nvPicPr>
+        <p:blipFill>
+          <a:blip r:embed="rId2"/>
+          <a:stretch>
+            <a:fillRect/>
+          </a:stretch>
+        </p:blipFill>
+        <p:spPr>
+          <a:xfrm>
+            <a:off x="5778994" y="2072635"/>
+            <a:ext cx="2657849" cy="2657849"/>
+          </a:xfrm>
+          <a:prstGeom prst="rect">
+            <a:avLst/>
+          </a:prstGeom>
+        </p:spPr>
+      </p:pic>
+      <p:sp>
+        <p:nvSpPr>
+          <p:cNvPr id="11" name="Text 7"/>
+          <p:cNvSpPr txBox="1"/>
+          <p:nvPr/>
+        </p:nvSpPr>
+        <p:spPr>
+          <a:xfrm>
+            <a:off x="9070825" y="1487420"/>
+            <a:ext cx="2292090" cy="268223"/>
           </a:xfrm>
           <a:prstGeom prst="rect">
             <a:avLst/>
@@ -6681,187 +6749,81 @@
               <a:buNone/>
             </a:pPr>
             <a:r>
-              <a:rPr lang="en-US" sz="2800" dirty="0">
+              <a:rPr lang="en-US" sz="1100" spc="300" kern="0" dirty="0">
                 <a:solidFill>
                   <a:srgbClr val="C9A96E"/>
+                </a:solidFill>
+                <a:latin typeface="Calibri" pitchFamily="34" charset="0"/>
+                <a:ea typeface="Calibri" pitchFamily="34" charset="-122"/>
+                <a:cs typeface="Calibri" pitchFamily="34" charset="-120"/>
+              </a:rPr>
+              <a:t>ПОДПИШИТЕСЬ НА НАШ TELEGRAM-КАНАЛ</a:t>
+            </a:r>
+            <a:endParaRPr lang="en-US" sz="1100" dirty="0"/>
+          </a:p>
+        </p:txBody>
+      </p:sp>
+      <p:sp>
+        <p:nvSpPr>
+          <p:cNvPr id="12" name="Text 8"/>
+          <p:cNvSpPr txBox="1"/>
+          <p:nvPr/>
+        </p:nvSpPr>
+        <p:spPr>
+          <a:xfrm>
+            <a:off x="9070825" y="2121403"/>
+            <a:ext cx="2292090" cy="902206"/>
+          </a:xfrm>
+          <a:prstGeom prst="rect">
+            <a:avLst/>
+          </a:prstGeom>
+          <a:noFill/>
+          <a:ln/>
+        </p:spPr>
+        <p:txBody>
+          <a:bodyPr wrap="square" lIns="0" tIns="0" rIns="0" bIns="0" rtlCol="0" anchor="t"/>
+          <a:lstStyle/>
+          <a:p>
+            <a:pPr algn="l" indent="0" marL="0">
+              <a:lnSpc>
+                <a:spcPct val="95000"/>
+              </a:lnSpc>
+              <a:buNone/>
+            </a:pPr>
+            <a:r>
+              <a:rPr lang="en-US" sz="2200" b="1" dirty="0">
+                <a:solidFill>
+                  <a:srgbClr val="F3EEE6"/>
                 </a:solidFill>
                 <a:latin typeface="Cambria" pitchFamily="34" charset="0"/>
                 <a:ea typeface="Cambria" pitchFamily="34" charset="-122"/>
                 <a:cs typeface="Cambria" pitchFamily="34" charset="-120"/>
               </a:rPr>
-              <a:t>01</a:t>
-            </a:r>
-            <a:endParaRPr lang="en-US" sz="2800" dirty="0"/>
-          </a:p>
-        </p:txBody>
-      </p:sp>
-      <p:sp>
-        <p:nvSpPr>
-          <p:cNvPr id="8" name="Text 6"/>
-          <p:cNvSpPr txBox="1"/>
-          <p:nvPr/>
-        </p:nvSpPr>
-        <p:spPr>
-          <a:xfrm>
-            <a:off x="5462002" y="1414268"/>
-            <a:ext cx="2584698" cy="536447"/>
-          </a:xfrm>
-          <a:prstGeom prst="rect">
-            <a:avLst/>
-          </a:prstGeom>
-          <a:noFill/>
-          <a:ln/>
-        </p:spPr>
-        <p:txBody>
-          <a:bodyPr wrap="square" lIns="0" tIns="0" rIns="0" bIns="0" rtlCol="0" anchor="t"/>
-          <a:lstStyle/>
-          <a:p>
-            <a:pPr algn="l" indent="0" marL="0">
-              <a:lnSpc>
-                <a:spcPct val="100000"/>
-              </a:lnSpc>
-              <a:buNone/>
-            </a:pPr>
-            <a:r>
-              <a:rPr lang="en-US" sz="2000" b="1" dirty="0">
-                <a:solidFill>
-                  <a:srgbClr val="F3EEE6"/>
-                </a:solidFill>
-                <a:latin typeface="Cambria" pitchFamily="34" charset="0"/>
-                <a:ea typeface="Cambria" pitchFamily="34" charset="-122"/>
-                <a:cs typeface="Cambria" pitchFamily="34" charset="-120"/>
-              </a:rPr>
-              <a:t>Шаблоны</a:t>
-            </a:r>
-            <a:endParaRPr lang="en-US" sz="2000" dirty="0"/>
-          </a:p>
-        </p:txBody>
-      </p:sp>
-      <p:sp>
-        <p:nvSpPr>
-          <p:cNvPr id="9" name="Text 7"/>
-          <p:cNvSpPr txBox="1"/>
-          <p:nvPr/>
-        </p:nvSpPr>
-        <p:spPr>
-          <a:xfrm>
-            <a:off x="5462002" y="2097019"/>
-            <a:ext cx="2584698" cy="1463036"/>
-          </a:xfrm>
-          <a:prstGeom prst="rect">
-            <a:avLst/>
-          </a:prstGeom>
-          <a:noFill/>
-          <a:ln/>
-        </p:spPr>
-        <p:txBody>
-          <a:bodyPr wrap="square" lIns="0" tIns="0" rIns="0" bIns="0" rtlCol="0" anchor="t"/>
-          <a:lstStyle/>
-          <a:p>
-            <a:pPr algn="l" indent="0" marL="0">
-              <a:lnSpc>
-                <a:spcPct val="100000"/>
-              </a:lnSpc>
-              <a:buNone/>
-            </a:pPr>
-            <a:r>
-              <a:rPr lang="en-US" sz="1350" dirty="0">
-                <a:solidFill>
-                  <a:srgbClr val="DDD8D0"/>
-                </a:solidFill>
-                <a:latin typeface="Calibri" pitchFamily="34" charset="0"/>
-                <a:ea typeface="Calibri" pitchFamily="34" charset="-122"/>
-                <a:cs typeface="Calibri" pitchFamily="34" charset="-120"/>
-              </a:rPr>
-              <a:t>Матрица ответственности, правило первого касания и скрипты передачи клиента — в один клик.</a:t>
-            </a:r>
-            <a:endParaRPr lang="en-US" sz="1350" dirty="0"/>
-          </a:p>
-        </p:txBody>
-      </p:sp>
-      <p:sp>
-        <p:nvSpPr>
-          <p:cNvPr id="10" name="Shape 8"/>
-          <p:cNvSpPr/>
-          <p:nvPr/>
-        </p:nvSpPr>
-        <p:spPr>
-          <a:xfrm>
-            <a:off x="5839953" y="4072118"/>
-            <a:ext cx="1828795" cy="1828795"/>
-          </a:xfrm>
-          <a:prstGeom prst="rect">
-            <a:avLst/>
-          </a:prstGeom>
-          <a:solidFill>
-            <a:srgbClr val="F3EEE6"/>
-          </a:solidFill>
-          <a:ln/>
-        </p:spPr>
-      </p:sp>
-      <p:sp>
-        <p:nvSpPr>
-          <p:cNvPr id="11" name="Text 9"/>
-          <p:cNvSpPr txBox="1"/>
-          <p:nvPr/>
-        </p:nvSpPr>
-        <p:spPr>
-          <a:xfrm>
-            <a:off x="5839953" y="4072118"/>
-            <a:ext cx="1828795" cy="1828795"/>
-          </a:xfrm>
-          <a:prstGeom prst="rect">
-            <a:avLst/>
-          </a:prstGeom>
-          <a:noFill/>
-          <a:ln/>
-        </p:spPr>
-        <p:txBody>
-          <a:bodyPr wrap="square" lIns="0" tIns="0" rIns="0" bIns="0" rtlCol="0" anchor="ctr"/>
-          <a:lstStyle/>
-          <a:p>
-            <a:pPr algn="ctr" indent="0" marL="0">
-              <a:lnSpc>
-                <a:spcPct val="100000"/>
-              </a:lnSpc>
-              <a:buNone/>
-            </a:pPr>
-            <a:r>
-              <a:rPr lang="en-US" sz="1100" b="1" spc="250" kern="0" dirty="0">
-                <a:solidFill>
-                  <a:srgbClr val="0C0A09"/>
-                </a:solidFill>
-                <a:latin typeface="Calibri" pitchFamily="34" charset="0"/>
-                <a:ea typeface="Calibri" pitchFamily="34" charset="-122"/>
-                <a:cs typeface="Calibri" pitchFamily="34" charset="-120"/>
-              </a:rPr>
-              <a:t>QR-КОД</a:t>
-            </a:r>
-            <a:endParaRPr lang="en-US" sz="1100" dirty="0"/>
-          </a:p>
-        </p:txBody>
-      </p:sp>
-      <p:sp>
-        <p:nvSpPr>
-          <p:cNvPr id="12" name="Shape 10"/>
-          <p:cNvSpPr/>
-          <p:nvPr/>
-        </p:nvSpPr>
-        <p:spPr>
-          <a:xfrm>
-            <a:off x="8558763" y="512063"/>
-            <a:ext cx="3121144" cy="5827761"/>
-          </a:xfrm>
-          <a:prstGeom prst="rect">
-            <a:avLst/>
-          </a:prstGeom>
-          <a:solidFill>
-            <a:srgbClr val="161412"/>
-          </a:solidFill>
+              <a:t>Оставайтесь на связи</a:t>
+            </a:r>
+            <a:endParaRPr lang="en-US" sz="2200" dirty="0"/>
+          </a:p>
+        </p:txBody>
+      </p:sp>
+      <p:sp>
+        <p:nvSpPr>
+          <p:cNvPr id="13" name="Shape 9"/>
+          <p:cNvSpPr/>
+          <p:nvPr/>
+        </p:nvSpPr>
+        <p:spPr>
+          <a:xfrm>
+            <a:off x="9070825" y="3243064"/>
+            <a:ext cx="2292090" cy="0"/>
+          </a:xfrm>
+          <a:prstGeom prst="line">
+            <a:avLst/>
+          </a:prstGeom>
+          <a:noFill/>
           <a:ln w="9525">
             <a:solidFill>
               <a:srgbClr val="C9A96E">
-                <a:alpha val="45000"/>
+                <a:alpha val="50000"/>
               </a:srgbClr>
             </a:solidFill>
             <a:prstDash val="solid"/>
@@ -6870,14 +6832,14 @@
       </p:sp>
       <p:sp>
         <p:nvSpPr>
-          <p:cNvPr id="13" name="Text 11"/>
-          <p:cNvSpPr txBox="1"/>
-          <p:nvPr/>
-        </p:nvSpPr>
-        <p:spPr>
-          <a:xfrm>
-            <a:off x="8826986" y="755902"/>
-            <a:ext cx="1219197" cy="487679"/>
+          <p:cNvPr id="14" name="Text 10"/>
+          <p:cNvSpPr txBox="1"/>
+          <p:nvPr/>
+        </p:nvSpPr>
+        <p:spPr>
+          <a:xfrm>
+            <a:off x="9070825" y="3364984"/>
+            <a:ext cx="2292090" cy="243839"/>
           </a:xfrm>
           <a:prstGeom prst="rect">
             <a:avLst/>
@@ -6896,7 +6858,200 @@
               <a:buNone/>
             </a:pPr>
             <a:r>
-              <a:rPr lang="en-US" sz="2800" dirty="0">
+              <a:rPr lang="en-US" sz="1050" spc="250" kern="0" dirty="0">
+                <a:solidFill>
+                  <a:srgbClr val="C9A96E"/>
+                </a:solidFill>
+                <a:latin typeface="Calibri" pitchFamily="34" charset="0"/>
+                <a:ea typeface="Calibri" pitchFamily="34" charset="-122"/>
+                <a:cs typeface="Calibri" pitchFamily="34" charset="-120"/>
+              </a:rPr>
+              <a:t>АНОНСЫ</a:t>
+            </a:r>
+            <a:endParaRPr lang="en-US" sz="1050" dirty="0"/>
+          </a:p>
+        </p:txBody>
+      </p:sp>
+      <p:sp>
+        <p:nvSpPr>
+          <p:cNvPr id="15" name="Text 11"/>
+          <p:cNvSpPr txBox="1"/>
+          <p:nvPr/>
+        </p:nvSpPr>
+        <p:spPr>
+          <a:xfrm>
+            <a:off x="9070825" y="3657591"/>
+            <a:ext cx="2292090" cy="365759"/>
+          </a:xfrm>
+          <a:prstGeom prst="rect">
+            <a:avLst/>
+          </a:prstGeom>
+          <a:noFill/>
+          <a:ln/>
+        </p:spPr>
+        <p:txBody>
+          <a:bodyPr wrap="square" lIns="0" tIns="0" rIns="0" bIns="0" rtlCol="0" anchor="t"/>
+          <a:lstStyle/>
+          <a:p>
+            <a:pPr algn="l" indent="0" marL="0">
+              <a:lnSpc>
+                <a:spcPct val="100000"/>
+              </a:lnSpc>
+              <a:buNone/>
+            </a:pPr>
+            <a:r>
+              <a:rPr lang="en-US" sz="1400" dirty="0">
+                <a:solidFill>
+                  <a:srgbClr val="F3EEE6"/>
+                </a:solidFill>
+                <a:latin typeface="Calibri" pitchFamily="34" charset="0"/>
+                <a:ea typeface="Calibri" pitchFamily="34" charset="-122"/>
+                <a:cs typeface="Calibri" pitchFamily="34" charset="-120"/>
+              </a:rPr>
+              <a:t>Объекты по СПб и ЛО</a:t>
+            </a:r>
+            <a:endParaRPr lang="en-US" sz="1400" dirty="0"/>
+          </a:p>
+        </p:txBody>
+      </p:sp>
+      <p:sp>
+        <p:nvSpPr>
+          <p:cNvPr id="16" name="Shape 12"/>
+          <p:cNvSpPr/>
+          <p:nvPr/>
+        </p:nvSpPr>
+        <p:spPr>
+          <a:xfrm>
+            <a:off x="9070825" y="4096502"/>
+            <a:ext cx="2292090" cy="0"/>
+          </a:xfrm>
+          <a:prstGeom prst="line">
+            <a:avLst/>
+          </a:prstGeom>
+          <a:noFill/>
+          <a:ln w="9525">
+            <a:solidFill>
+              <a:srgbClr val="C9A96E">
+                <a:alpha val="50000"/>
+              </a:srgbClr>
+            </a:solidFill>
+            <a:prstDash val="solid"/>
+          </a:ln>
+        </p:spPr>
+      </p:sp>
+      <p:sp>
+        <p:nvSpPr>
+          <p:cNvPr id="17" name="Text 13"/>
+          <p:cNvSpPr txBox="1"/>
+          <p:nvPr/>
+        </p:nvSpPr>
+        <p:spPr>
+          <a:xfrm>
+            <a:off x="9070825" y="4218421"/>
+            <a:ext cx="2292090" cy="243839"/>
+          </a:xfrm>
+          <a:prstGeom prst="rect">
+            <a:avLst/>
+          </a:prstGeom>
+          <a:noFill/>
+          <a:ln/>
+        </p:spPr>
+        <p:txBody>
+          <a:bodyPr wrap="square" lIns="0" tIns="0" rIns="0" bIns="0" rtlCol="0" anchor="t"/>
+          <a:lstStyle/>
+          <a:p>
+            <a:pPr algn="l" indent="0" marL="0">
+              <a:lnSpc>
+                <a:spcPct val="100000"/>
+              </a:lnSpc>
+              <a:buNone/>
+            </a:pPr>
+            <a:r>
+              <a:rPr lang="en-US" sz="1050" spc="250" kern="0" dirty="0">
+                <a:solidFill>
+                  <a:srgbClr val="C9A96E"/>
+                </a:solidFill>
+                <a:latin typeface="Calibri" pitchFamily="34" charset="0"/>
+                <a:ea typeface="Calibri" pitchFamily="34" charset="-122"/>
+                <a:cs typeface="Calibri" pitchFamily="34" charset="-120"/>
+              </a:rPr>
+              <a:t>МАТЕРИАЛЫ</a:t>
+            </a:r>
+            <a:endParaRPr lang="en-US" sz="1050" dirty="0"/>
+          </a:p>
+        </p:txBody>
+      </p:sp>
+      <p:sp>
+        <p:nvSpPr>
+          <p:cNvPr id="18" name="Text 14"/>
+          <p:cNvSpPr txBox="1"/>
+          <p:nvPr/>
+        </p:nvSpPr>
+        <p:spPr>
+          <a:xfrm>
+            <a:off x="9070825" y="4511029"/>
+            <a:ext cx="2292090" cy="1097277"/>
+          </a:xfrm>
+          <a:prstGeom prst="rect">
+            <a:avLst/>
+          </a:prstGeom>
+          <a:noFill/>
+          <a:ln/>
+        </p:spPr>
+        <p:txBody>
+          <a:bodyPr wrap="square" lIns="0" tIns="0" rIns="0" bIns="0" rtlCol="0" anchor="t"/>
+          <a:lstStyle/>
+          <a:p>
+            <a:pPr algn="l" indent="0" marL="0">
+              <a:lnSpc>
+                <a:spcPct val="100000"/>
+              </a:lnSpc>
+              <a:buNone/>
+            </a:pPr>
+            <a:r>
+              <a:rPr lang="en-US" sz="1400" dirty="0">
+                <a:solidFill>
+                  <a:srgbClr val="F3EEE6"/>
+                </a:solidFill>
+                <a:latin typeface="Calibri" pitchFamily="34" charset="0"/>
+                <a:ea typeface="Calibri" pitchFamily="34" charset="-122"/>
+                <a:cs typeface="Calibri" pitchFamily="34" charset="-120"/>
+              </a:rPr>
+              <a:t>Скрипты, кейсы, шаблоны и материалы по загородной недвижимости в СПб и ЛО</a:t>
+            </a:r>
+            <a:endParaRPr lang="en-US" sz="1400" dirty="0"/>
+          </a:p>
+        </p:txBody>
+      </p:sp>
+      <p:sp>
+        <p:nvSpPr>
+          <p:cNvPr id="19" name="Text 15"/>
+          <p:cNvSpPr txBox="1"/>
+          <p:nvPr/>
+        </p:nvSpPr>
+        <p:spPr>
+          <a:xfrm>
+            <a:off x="5608306" y="5266931"/>
+            <a:ext cx="2999225" cy="487679"/>
+          </a:xfrm>
+          <a:prstGeom prst="rect">
+            <a:avLst/>
+          </a:prstGeom>
+          <a:noFill/>
+          <a:ln/>
+        </p:spPr>
+        <p:txBody>
+          <a:bodyPr wrap="square" lIns="0" tIns="0" rIns="0" bIns="0" rtlCol="0" anchor="t"/>
+          <a:lstStyle/>
+          <a:p>
+            <a:pPr algn="ctr" indent="0" marL="0">
+              <a:lnSpc>
+                <a:spcPct val="100000"/>
+              </a:lnSpc>
+              <a:buNone/>
+            </a:pPr>
+            <a:r>
+              <a:rPr lang="en-US" sz="2200" b="1" dirty="0">
                 <a:solidFill>
                   <a:srgbClr val="C9A96E"/>
                 </a:solidFill>
@@ -6904,155 +7059,9 @@
                 <a:ea typeface="Cambria" pitchFamily="34" charset="-122"/>
                 <a:cs typeface="Cambria" pitchFamily="34" charset="-120"/>
               </a:rPr>
-              <a:t>02</a:t>
-            </a:r>
-            <a:endParaRPr lang="en-US" sz="2800" dirty="0"/>
-          </a:p>
-        </p:txBody>
-      </p:sp>
-      <p:sp>
-        <p:nvSpPr>
-          <p:cNvPr id="14" name="Text 12"/>
-          <p:cNvSpPr txBox="1"/>
-          <p:nvPr/>
-        </p:nvSpPr>
-        <p:spPr>
-          <a:xfrm>
-            <a:off x="8826986" y="1414268"/>
-            <a:ext cx="2584698" cy="536447"/>
-          </a:xfrm>
-          <a:prstGeom prst="rect">
-            <a:avLst/>
-          </a:prstGeom>
-          <a:noFill/>
-          <a:ln/>
-        </p:spPr>
-        <p:txBody>
-          <a:bodyPr wrap="square" lIns="0" tIns="0" rIns="0" bIns="0" rtlCol="0" anchor="t"/>
-          <a:lstStyle/>
-          <a:p>
-            <a:pPr algn="l" indent="0" marL="0">
-              <a:lnSpc>
-                <a:spcPct val="100000"/>
-              </a:lnSpc>
-              <a:buNone/>
-            </a:pPr>
-            <a:r>
-              <a:rPr lang="en-US" sz="2000" b="1" dirty="0">
-                <a:solidFill>
-                  <a:srgbClr val="F3EEE6"/>
-                </a:solidFill>
-                <a:latin typeface="Cambria" pitchFamily="34" charset="0"/>
-                <a:ea typeface="Cambria" pitchFamily="34" charset="-122"/>
-                <a:cs typeface="Cambria" pitchFamily="34" charset="-120"/>
-              </a:rPr>
-              <a:t>Telegram-канал</a:t>
-            </a:r>
-            <a:endParaRPr lang="en-US" sz="2000" dirty="0"/>
-          </a:p>
-        </p:txBody>
-      </p:sp>
-      <p:sp>
-        <p:nvSpPr>
-          <p:cNvPr id="15" name="Text 13"/>
-          <p:cNvSpPr txBox="1"/>
-          <p:nvPr/>
-        </p:nvSpPr>
-        <p:spPr>
-          <a:xfrm>
-            <a:off x="8826986" y="2097019"/>
-            <a:ext cx="2584698" cy="1463036"/>
-          </a:xfrm>
-          <a:prstGeom prst="rect">
-            <a:avLst/>
-          </a:prstGeom>
-          <a:noFill/>
-          <a:ln/>
-        </p:spPr>
-        <p:txBody>
-          <a:bodyPr wrap="square" lIns="0" tIns="0" rIns="0" bIns="0" rtlCol="0" anchor="t"/>
-          <a:lstStyle/>
-          <a:p>
-            <a:pPr algn="l" indent="0" marL="0">
-              <a:lnSpc>
-                <a:spcPct val="100000"/>
-              </a:lnSpc>
-              <a:buNone/>
-            </a:pPr>
-            <a:r>
-              <a:rPr lang="en-US" sz="1350" dirty="0">
-                <a:solidFill>
-                  <a:srgbClr val="DDD8D0"/>
-                </a:solidFill>
-                <a:latin typeface="Calibri" pitchFamily="34" charset="0"/>
-                <a:ea typeface="Calibri" pitchFamily="34" charset="-122"/>
-                <a:cs typeface="Calibri" pitchFamily="34" charset="-120"/>
-              </a:rPr>
-              <a:t>Анонсы объектов по СПб и ЛО. Скрипты, кейсы, шаблоны и материалы по загородной недвижимости.</a:t>
-            </a:r>
-            <a:endParaRPr lang="en-US" sz="1350" dirty="0"/>
-          </a:p>
-        </p:txBody>
-      </p:sp>
-      <p:sp>
-        <p:nvSpPr>
-          <p:cNvPr id="16" name="Shape 14"/>
-          <p:cNvSpPr/>
-          <p:nvPr/>
-        </p:nvSpPr>
-        <p:spPr>
-          <a:xfrm>
-            <a:off x="9204937" y="4072118"/>
-            <a:ext cx="1828795" cy="1828795"/>
-          </a:xfrm>
-          <a:prstGeom prst="rect">
-            <a:avLst/>
-          </a:prstGeom>
-          <a:solidFill>
-            <a:srgbClr val="F3EEE6"/>
-          </a:solidFill>
-          <a:ln/>
-        </p:spPr>
-      </p:sp>
-      <p:sp>
-        <p:nvSpPr>
-          <p:cNvPr id="17" name="Text 15"/>
-          <p:cNvSpPr txBox="1"/>
-          <p:nvPr/>
-        </p:nvSpPr>
-        <p:spPr>
-          <a:xfrm>
-            <a:off x="9204937" y="4072118"/>
-            <a:ext cx="1828795" cy="1828795"/>
-          </a:xfrm>
-          <a:prstGeom prst="rect">
-            <a:avLst/>
-          </a:prstGeom>
-          <a:noFill/>
-          <a:ln/>
-        </p:spPr>
-        <p:txBody>
-          <a:bodyPr wrap="square" lIns="0" tIns="0" rIns="0" bIns="0" rtlCol="0" anchor="ctr"/>
-          <a:lstStyle/>
-          <a:p>
-            <a:pPr algn="ctr" indent="0" marL="0">
-              <a:lnSpc>
-                <a:spcPct val="100000"/>
-              </a:lnSpc>
-              <a:buNone/>
-            </a:pPr>
-            <a:r>
-              <a:rPr lang="en-US" sz="1100" b="1" spc="250" kern="0" dirty="0">
-                <a:solidFill>
-                  <a:srgbClr val="0C0A09"/>
-                </a:solidFill>
-                <a:latin typeface="Calibri" pitchFamily="34" charset="0"/>
-                <a:ea typeface="Calibri" pitchFamily="34" charset="-122"/>
-                <a:cs typeface="Calibri" pitchFamily="34" charset="-120"/>
-              </a:rPr>
-              <a:t>QR-КОД</a:t>
-            </a:r>
-            <a:endParaRPr lang="en-US" sz="1100" dirty="0"/>
+              <a:t>t.me/puzzlerealty</a:t>
+            </a:r>
+            <a:endParaRPr lang="en-US" sz="2200" dirty="0"/>
           </a:p>
         </p:txBody>
       </p:sp>

</xml_diff>